<commit_message>
Laboratoire 11: correction dossier images
</commit_message>
<xml_diff>
--- a/lab11/presentation.pptx
+++ b/lab11/presentation.pptx
@@ -4,7 +4,17 @@
   <p:sldMasterIdLst>
     <p:sldMasterId id="2147483648" r:id="rId1"/>
   </p:sldMasterIdLst>
-  <p:sldIdLst/>
+  <p:sldIdLst>
+    <p:sldId id="256" r:id="rId2"/>
+    <p:sldId id="257" r:id="rId3"/>
+    <p:sldId id="258" r:id="rId4"/>
+    <p:sldId id="259" r:id="rId5"/>
+    <p:sldId id="260" r:id="rId6"/>
+    <p:sldId id="261" r:id="rId7"/>
+    <p:sldId id="262" r:id="rId8"/>
+    <p:sldId id="263" r:id="rId9"/>
+    <p:sldId id="264" r:id="rId10"/>
+  </p:sldIdLst>
   <p:sldSz cx="9144000" cy="5143500" type="screen16x9"/>
   <p:notesSz cx="6858000" cy="9144000"/>
   <p:defaultTextStyle>
@@ -3069,6 +3079,1577 @@
     </p:otherStyle>
   </p:txStyles>
 </p:sldMaster>
+</file>
+
+<file path=ppt/slides/slide1.xml><?xml version="1.0" encoding="utf-8"?>
+<p:sld xmlns:a="http://schemas.openxmlformats.org/drawingml/2006/main" xmlns:r="http://schemas.openxmlformats.org/officeDocument/2006/relationships" xmlns:p="http://schemas.openxmlformats.org/presentationml/2006/main">
+  <p:cSld>
+    <p:spTree>
+      <p:nvGrpSpPr>
+        <p:cNvPr id="1" name=""/>
+        <p:cNvGrpSpPr/>
+        <p:nvPr/>
+      </p:nvGrpSpPr>
+      <p:grpSpPr>
+        <a:xfrm>
+          <a:off x="0" y="0"/>
+          <a:ext cx="0" cy="0"/>
+          <a:chOff x="0" y="0"/>
+          <a:chExt cx="0" cy="0"/>
+        </a:xfrm>
+      </p:grpSpPr>
+      <p:sp>
+        <p:nvSpPr>
+          <p:cNvPr id="2" name="Title 1"/>
+          <p:cNvSpPr>
+            <a:spLocks noGrp="1"/>
+          </p:cNvSpPr>
+          <p:nvPr>
+            <p:ph type="ctrTitle"/>
+          </p:nvPr>
+        </p:nvSpPr>
+        <p:spPr>
+          <a:xfrm>
+            <a:off x="685800" y="1597819"/>
+            <a:ext cx="7772400" cy="1102519"/>
+          </a:xfrm>
+        </p:spPr>
+        <p:txBody>
+          <a:bodyPr/>
+          <a:lstStyle/>
+          <a:p>
+            <a:pPr lvl="0" indent="0" marL="0">
+              <a:buNone/>
+            </a:pPr>
+            <a:r>
+              <a:rPr/>
+              <a:t>Лабораторная работа №11: Текстовой редактор emacs</a:t>
+            </a:r>
+          </a:p>
+        </p:txBody>
+      </p:sp>
+      <p:sp>
+        <p:nvSpPr>
+          <p:cNvPr id="3" name="Subtitle 2"/>
+          <p:cNvSpPr>
+            <a:spLocks noGrp="1"/>
+          </p:cNvSpPr>
+          <p:nvPr>
+            <p:ph idx="1" type="subTitle"/>
+          </p:nvPr>
+        </p:nvSpPr>
+        <p:spPr>
+          <a:xfrm>
+            <a:off x="1371600" y="2914650"/>
+            <a:ext cx="6400800" cy="1314450"/>
+          </a:xfrm>
+        </p:spPr>
+        <p:txBody>
+          <a:bodyPr/>
+          <a:lstStyle/>
+          <a:p>
+            <a:pPr lvl="0" indent="0" marL="0">
+              <a:buNone/>
+            </a:pPr>
+            <a:br/>
+            <a:br/>
+            <a:r>
+              <a:rPr/>
+              <a:t>LISSOM BAYEM ODILLON NATHANAEL</a:t>
+            </a:r>
+          </a:p>
+        </p:txBody>
+      </p:sp>
+    </p:spTree>
+  </p:cSld>
+</p:sld>
+</file>
+
+<file path=ppt/slides/slide2.xml><?xml version="1.0" encoding="utf-8"?>
+<p:sld xmlns:a="http://schemas.openxmlformats.org/drawingml/2006/main" xmlns:r="http://schemas.openxmlformats.org/officeDocument/2006/relationships" xmlns:p="http://schemas.openxmlformats.org/presentationml/2006/main">
+  <p:cSld>
+    <p:spTree>
+      <p:nvGrpSpPr>
+        <p:cNvPr id="1" name=""/>
+        <p:cNvGrpSpPr/>
+        <p:nvPr/>
+      </p:nvGrpSpPr>
+      <p:grpSpPr>
+        <a:xfrm>
+          <a:off x="0" y="0"/>
+          <a:ext cx="0" cy="0"/>
+          <a:chOff x="0" y="0"/>
+          <a:chExt cx="0" cy="0"/>
+        </a:xfrm>
+      </p:grpSpPr>
+      <p:sp>
+        <p:nvSpPr>
+          <p:cNvPr id="2" name="Title 1"/>
+          <p:cNvSpPr>
+            <a:spLocks noGrp="1"/>
+          </p:cNvSpPr>
+          <p:nvPr>
+            <p:ph type="title"/>
+          </p:nvPr>
+        </p:nvSpPr>
+        <p:spPr/>
+        <p:txBody>
+          <a:bodyPr/>
+          <a:lstStyle/>
+          <a:p>
+            <a:pPr lvl="0" indent="0" marL="0">
+              <a:buNone/>
+            </a:pPr>
+            <a:r>
+              <a:rPr/>
+              <a:t>Цель работы</a:t>
+            </a:r>
+          </a:p>
+        </p:txBody>
+      </p:sp>
+      <p:sp>
+        <p:nvSpPr>
+          <p:cNvPr id="3" name="Content Placeholder 2"/>
+          <p:cNvSpPr>
+            <a:spLocks noGrp="1"/>
+          </p:cNvSpPr>
+          <p:nvPr>
+            <p:ph idx="1"/>
+          </p:nvPr>
+        </p:nvSpPr>
+        <p:spPr/>
+        <p:txBody>
+          <a:bodyPr/>
+          <a:lstStyle/>
+          <a:p>
+            <a:pPr lvl="0"/>
+            <a:r>
+              <a:rPr/>
+              <a:t>Познакомиться с Emacs</a:t>
+            </a:r>
+          </a:p>
+          <a:p>
+            <a:pPr lvl="0"/>
+            <a:r>
+              <a:rPr/>
+              <a:t>Получить практические навыки работы</a:t>
+            </a:r>
+          </a:p>
+        </p:txBody>
+      </p:sp>
+    </p:spTree>
+  </p:cSld>
+</p:sld>
+</file>
+
+<file path=ppt/slides/slide3.xml><?xml version="1.0" encoding="utf-8"?>
+<p:sld xmlns:a="http://schemas.openxmlformats.org/drawingml/2006/main" xmlns:r="http://schemas.openxmlformats.org/officeDocument/2006/relationships" xmlns:p="http://schemas.openxmlformats.org/presentationml/2006/main">
+  <p:cSld>
+    <p:spTree>
+      <p:nvGrpSpPr>
+        <p:cNvPr id="1" name=""/>
+        <p:cNvGrpSpPr/>
+        <p:nvPr/>
+      </p:nvGrpSpPr>
+      <p:grpSpPr>
+        <a:xfrm>
+          <a:off x="0" y="0"/>
+          <a:ext cx="0" cy="0"/>
+          <a:chOff x="0" y="0"/>
+          <a:chExt cx="0" cy="0"/>
+        </a:xfrm>
+      </p:grpSpPr>
+      <p:sp>
+        <p:nvSpPr>
+          <p:cNvPr id="2" name="Title 1"/>
+          <p:cNvSpPr>
+            <a:spLocks noGrp="1"/>
+          </p:cNvSpPr>
+          <p:nvPr>
+            <p:ph type="title"/>
+          </p:nvPr>
+        </p:nvSpPr>
+        <p:spPr/>
+        <p:txBody>
+          <a:bodyPr/>
+          <a:lstStyle/>
+          <a:p>
+            <a:pPr lvl="0" indent="0" marL="0">
+              <a:buNone/>
+            </a:pPr>
+            <a:r>
+              <a:rPr/>
+              <a:t>Основные понятия</a:t>
+            </a:r>
+          </a:p>
+        </p:txBody>
+      </p:sp>
+      <p:sp>
+        <p:nvSpPr>
+          <p:cNvPr id="3" name="Content Placeholder 2"/>
+          <p:cNvSpPr>
+            <a:spLocks noGrp="1"/>
+          </p:cNvSpPr>
+          <p:nvPr>
+            <p:ph idx="1"/>
+          </p:nvPr>
+        </p:nvSpPr>
+        <p:spPr/>
+        <p:txBody>
+          <a:bodyPr/>
+          <a:lstStyle/>
+          <a:p>
+            <a:pPr lvl="0"/>
+            <a:r>
+              <a:rPr b="1"/>
+              <a:t>Буфер</a:t>
+            </a:r>
+            <a:r>
+              <a:rPr/>
+              <a:t> – текст в памяти</a:t>
+            </a:r>
+          </a:p>
+          <a:p>
+            <a:pPr lvl="0"/>
+            <a:r>
+              <a:rPr b="1"/>
+              <a:t>Фрейм</a:t>
+            </a:r>
+            <a:r>
+              <a:rPr/>
+              <a:t> – окно приложения</a:t>
+            </a:r>
+          </a:p>
+          <a:p>
+            <a:pPr lvl="0"/>
+            <a:r>
+              <a:rPr b="1"/>
+              <a:t>Окно</a:t>
+            </a:r>
+            <a:r>
+              <a:rPr/>
+              <a:t> – область, отображающая буфер</a:t>
+            </a:r>
+          </a:p>
+          <a:p>
+            <a:pPr lvl="0"/>
+            <a:r>
+              <a:rPr b="1"/>
+              <a:t>Точка вставки</a:t>
+            </a:r>
+            <a:r>
+              <a:rPr/>
+              <a:t> – место вставки/удаления</a:t>
+            </a:r>
+          </a:p>
+        </p:txBody>
+      </p:sp>
+    </p:spTree>
+  </p:cSld>
+</p:sld>
+</file>
+
+<file path=ppt/slides/slide4.xml><?xml version="1.0" encoding="utf-8"?>
+<p:sld xmlns:a="http://schemas.openxmlformats.org/drawingml/2006/main" xmlns:r="http://schemas.openxmlformats.org/officeDocument/2006/relationships" xmlns:p="http://schemas.openxmlformats.org/presentationml/2006/main">
+  <p:cSld>
+    <p:spTree>
+      <p:nvGrpSpPr>
+        <p:cNvPr id="1" name=""/>
+        <p:cNvGrpSpPr/>
+        <p:nvPr/>
+      </p:nvGrpSpPr>
+      <p:grpSpPr>
+        <a:xfrm>
+          <a:off x="0" y="0"/>
+          <a:ext cx="0" cy="0"/>
+          <a:chOff x="0" y="0"/>
+          <a:chExt cx="0" cy="0"/>
+        </a:xfrm>
+      </p:grpSpPr>
+      <p:sp>
+        <p:nvSpPr>
+          <p:cNvPr id="2" name="Title 1"/>
+          <p:cNvSpPr>
+            <a:spLocks noGrp="1"/>
+          </p:cNvSpPr>
+          <p:nvPr>
+            <p:ph type="title"/>
+          </p:nvPr>
+        </p:nvSpPr>
+        <p:spPr/>
+        <p:txBody>
+          <a:bodyPr/>
+          <a:lstStyle/>
+          <a:p>
+            <a:pPr lvl="0" indent="0" marL="0">
+              <a:buNone/>
+            </a:pPr>
+            <a:r>
+              <a:rPr/>
+              <a:t>Команды (C=Ctrl, M=Alt)</a:t>
+            </a:r>
+          </a:p>
+        </p:txBody>
+      </p:sp>
+      <p:graphicFrame>
+        <p:nvGraphicFramePr>
+          <p:cNvPr id="6" name="Content Placeholder 5"/>
+          <p:cNvGraphicFramePr>
+            <a:graphicFrameLocks noGrp="1"/>
+          </p:cNvGraphicFramePr>
+          <p:nvPr>
+            <p:ph idx="1"/>
+          </p:nvPr>
+        </p:nvGraphicFramePr>
+        <p:xfrm>
+          <a:off x="457200" y="1193800"/>
+          <a:ext cx="8229600" cy="3390900"/>
+        </p:xfrm>
+        <a:graphic>
+          <a:graphicData uri="http://schemas.openxmlformats.org/drawingml/2006/table">
+            <a:tbl>
+              <a:tblPr firstRow="1" bandRow="1">
+                <a:tableStyleId>{5C22544A-7EE6-4342-B048-85BDC9FD1C3A}</a:tableStyleId>
+              </a:tblPr>
+              <a:tblGrid>
+                <a:gridCol w="4114800"/>
+                <a:gridCol w="4114800"/>
+              </a:tblGrid>
+              <a:tr h="0">
+                <a:tc>
+                  <a:txBody>
+                    <a:bodyPr/>
+                    <a:lstStyle/>
+                    <a:p>
+                      <a:pPr lvl="0" indent="0" marL="0">
+                        <a:buNone/>
+                      </a:pPr>
+                      <a:r>
+                        <a:rPr/>
+                        <a:t>Команда</a:t>
+                      </a:r>
+                    </a:p>
+                  </a:txBody>
+                  <a:tcPr/>
+                </a:tc>
+                <a:tc>
+                  <a:txBody>
+                    <a:bodyPr/>
+                    <a:lstStyle/>
+                    <a:p>
+                      <a:pPr lvl="0" indent="0" marL="0">
+                        <a:buNone/>
+                      </a:pPr>
+                      <a:r>
+                        <a:rPr/>
+                        <a:t>Действие</a:t>
+                      </a:r>
+                    </a:p>
+                  </a:txBody>
+                  <a:tcPr/>
+                </a:tc>
+              </a:tr>
+              <a:tr h="0">
+                <a:tc>
+                  <a:txBody>
+                    <a:bodyPr/>
+                    <a:lstStyle/>
+                    <a:p>
+                      <a:pPr lvl="0" indent="0" marL="0">
+                        <a:buNone/>
+                      </a:pPr>
+                      <a:r>
+                        <a:rPr/>
+                        <a:t>C-x C-f</a:t>
+                      </a:r>
+                    </a:p>
+                  </a:txBody>
+                </a:tc>
+                <a:tc>
+                  <a:txBody>
+                    <a:bodyPr/>
+                    <a:lstStyle/>
+                    <a:p>
+                      <a:pPr lvl="0" indent="0" marL="0">
+                        <a:buNone/>
+                      </a:pPr>
+                      <a:r>
+                        <a:rPr/>
+                        <a:t>Открыть файл</a:t>
+                      </a:r>
+                    </a:p>
+                  </a:txBody>
+                </a:tc>
+              </a:tr>
+              <a:tr h="0">
+                <a:tc>
+                  <a:txBody>
+                    <a:bodyPr/>
+                    <a:lstStyle/>
+                    <a:p>
+                      <a:pPr lvl="0" indent="0" marL="0">
+                        <a:buNone/>
+                      </a:pPr>
+                      <a:r>
+                        <a:rPr/>
+                        <a:t>C-x C-s</a:t>
+                      </a:r>
+                    </a:p>
+                  </a:txBody>
+                </a:tc>
+                <a:tc>
+                  <a:txBody>
+                    <a:bodyPr/>
+                    <a:lstStyle/>
+                    <a:p>
+                      <a:pPr lvl="0" indent="0" marL="0">
+                        <a:buNone/>
+                      </a:pPr>
+                      <a:r>
+                        <a:rPr/>
+                        <a:t>Сохранить</a:t>
+                      </a:r>
+                    </a:p>
+                  </a:txBody>
+                </a:tc>
+              </a:tr>
+              <a:tr h="0">
+                <a:tc>
+                  <a:txBody>
+                    <a:bodyPr/>
+                    <a:lstStyle/>
+                    <a:p>
+                      <a:pPr lvl="0" indent="0" marL="0">
+                        <a:buNone/>
+                      </a:pPr>
+                      <a:r>
+                        <a:rPr/>
+                        <a:t>C-x C-c</a:t>
+                      </a:r>
+                    </a:p>
+                  </a:txBody>
+                </a:tc>
+                <a:tc>
+                  <a:txBody>
+                    <a:bodyPr/>
+                    <a:lstStyle/>
+                    <a:p>
+                      <a:pPr lvl="0" indent="0" marL="0">
+                        <a:buNone/>
+                      </a:pPr>
+                      <a:r>
+                        <a:rPr/>
+                        <a:t>Выйти</a:t>
+                      </a:r>
+                    </a:p>
+                  </a:txBody>
+                </a:tc>
+              </a:tr>
+              <a:tr h="0">
+                <a:tc>
+                  <a:txBody>
+                    <a:bodyPr/>
+                    <a:lstStyle/>
+                    <a:p>
+                      <a:pPr lvl="0" indent="0" marL="0">
+                        <a:buNone/>
+                      </a:pPr>
+                      <a:r>
+                        <a:rPr/>
+                        <a:t>C-x C-b</a:t>
+                      </a:r>
+                    </a:p>
+                  </a:txBody>
+                </a:tc>
+                <a:tc>
+                  <a:txBody>
+                    <a:bodyPr/>
+                    <a:lstStyle/>
+                    <a:p>
+                      <a:pPr lvl="0" indent="0" marL="0">
+                        <a:buNone/>
+                      </a:pPr>
+                      <a:r>
+                        <a:rPr/>
+                        <a:t>Список буферов</a:t>
+                      </a:r>
+                    </a:p>
+                  </a:txBody>
+                </a:tc>
+              </a:tr>
+              <a:tr h="0">
+                <a:tc>
+                  <a:txBody>
+                    <a:bodyPr/>
+                    <a:lstStyle/>
+                    <a:p>
+                      <a:pPr lvl="0" indent="0" marL="0">
+                        <a:buNone/>
+                      </a:pPr>
+                      <a:r>
+                        <a:rPr/>
+                        <a:t>C-x b</a:t>
+                      </a:r>
+                    </a:p>
+                  </a:txBody>
+                </a:tc>
+                <a:tc>
+                  <a:txBody>
+                    <a:bodyPr/>
+                    <a:lstStyle/>
+                    <a:p>
+                      <a:pPr lvl="0" indent="0" marL="0">
+                        <a:buNone/>
+                      </a:pPr>
+                      <a:r>
+                        <a:rPr/>
+                        <a:t>Переключить буфер</a:t>
+                      </a:r>
+                    </a:p>
+                  </a:txBody>
+                </a:tc>
+              </a:tr>
+              <a:tr h="0">
+                <a:tc>
+                  <a:txBody>
+                    <a:bodyPr/>
+                    <a:lstStyle/>
+                    <a:p>
+                      <a:pPr lvl="0" indent="0" marL="0">
+                        <a:buNone/>
+                      </a:pPr>
+                      <a:r>
+                        <a:rPr/>
+                        <a:t>C-x 0</a:t>
+                      </a:r>
+                    </a:p>
+                  </a:txBody>
+                </a:tc>
+                <a:tc>
+                  <a:txBody>
+                    <a:bodyPr/>
+                    <a:lstStyle/>
+                    <a:p>
+                      <a:pPr lvl="0" indent="0" marL="0">
+                        <a:buNone/>
+                      </a:pPr>
+                      <a:r>
+                        <a:rPr/>
+                        <a:t>Закрыть окно</a:t>
+                      </a:r>
+                    </a:p>
+                  </a:txBody>
+                </a:tc>
+              </a:tr>
+              <a:tr h="0">
+                <a:tc>
+                  <a:txBody>
+                    <a:bodyPr/>
+                    <a:lstStyle/>
+                    <a:p>
+                      <a:pPr lvl="0" indent="0" marL="0">
+                        <a:buNone/>
+                      </a:pPr>
+                      <a:r>
+                        <a:rPr/>
+                        <a:t>C-x 1</a:t>
+                      </a:r>
+                    </a:p>
+                  </a:txBody>
+                </a:tc>
+                <a:tc>
+                  <a:txBody>
+                    <a:bodyPr/>
+                    <a:lstStyle/>
+                    <a:p>
+                      <a:pPr lvl="0" indent="0" marL="0">
+                        <a:buNone/>
+                      </a:pPr>
+                      <a:r>
+                        <a:rPr/>
+                        <a:t>Одно окно</a:t>
+                      </a:r>
+                    </a:p>
+                  </a:txBody>
+                </a:tc>
+              </a:tr>
+              <a:tr h="0">
+                <a:tc>
+                  <a:txBody>
+                    <a:bodyPr/>
+                    <a:lstStyle/>
+                    <a:p>
+                      <a:pPr lvl="0" indent="0" marL="0">
+                        <a:buNone/>
+                      </a:pPr>
+                      <a:r>
+                        <a:rPr/>
+                        <a:t>C-x 2</a:t>
+                      </a:r>
+                    </a:p>
+                  </a:txBody>
+                </a:tc>
+                <a:tc>
+                  <a:txBody>
+                    <a:bodyPr/>
+                    <a:lstStyle/>
+                    <a:p>
+                      <a:pPr lvl="0" indent="0" marL="0">
+                        <a:buNone/>
+                      </a:pPr>
+                      <a:r>
+                        <a:rPr/>
+                        <a:t>Разделить по горизонтали</a:t>
+                      </a:r>
+                    </a:p>
+                  </a:txBody>
+                </a:tc>
+              </a:tr>
+              <a:tr h="0">
+                <a:tc>
+                  <a:txBody>
+                    <a:bodyPr/>
+                    <a:lstStyle/>
+                    <a:p>
+                      <a:pPr lvl="0" indent="0" marL="0">
+                        <a:buNone/>
+                      </a:pPr>
+                      <a:r>
+                        <a:rPr/>
+                        <a:t>C-x 3</a:t>
+                      </a:r>
+                    </a:p>
+                  </a:txBody>
+                </a:tc>
+                <a:tc>
+                  <a:txBody>
+                    <a:bodyPr/>
+                    <a:lstStyle/>
+                    <a:p>
+                      <a:pPr lvl="0" indent="0" marL="0">
+                        <a:buNone/>
+                      </a:pPr>
+                      <a:r>
+                        <a:rPr/>
+                        <a:t>Разделить по вертикали</a:t>
+                      </a:r>
+                    </a:p>
+                  </a:txBody>
+                </a:tc>
+              </a:tr>
+              <a:tr h="0">
+                <a:tc>
+                  <a:txBody>
+                    <a:bodyPr/>
+                    <a:lstStyle/>
+                    <a:p>
+                      <a:pPr lvl="0" indent="0" marL="0">
+                        <a:buNone/>
+                      </a:pPr>
+                      <a:r>
+                        <a:rPr/>
+                        <a:t>C-s</a:t>
+                      </a:r>
+                    </a:p>
+                  </a:txBody>
+                </a:tc>
+                <a:tc>
+                  <a:txBody>
+                    <a:bodyPr/>
+                    <a:lstStyle/>
+                    <a:p>
+                      <a:pPr lvl="0" indent="0" marL="0">
+                        <a:buNone/>
+                      </a:pPr>
+                      <a:r>
+                        <a:rPr/>
+                        <a:t>Поиск вперёд</a:t>
+                      </a:r>
+                    </a:p>
+                  </a:txBody>
+                </a:tc>
+              </a:tr>
+              <a:tr h="0">
+                <a:tc>
+                  <a:txBody>
+                    <a:bodyPr/>
+                    <a:lstStyle/>
+                    <a:p>
+                      <a:pPr lvl="0" indent="0" marL="0">
+                        <a:buNone/>
+                      </a:pPr>
+                      <a:r>
+                        <a:rPr/>
+                        <a:t>C-r</a:t>
+                      </a:r>
+                    </a:p>
+                  </a:txBody>
+                </a:tc>
+                <a:tc>
+                  <a:txBody>
+                    <a:bodyPr/>
+                    <a:lstStyle/>
+                    <a:p>
+                      <a:pPr lvl="0" indent="0" marL="0">
+                        <a:buNone/>
+                      </a:pPr>
+                      <a:r>
+                        <a:rPr/>
+                        <a:t>Поиск назад</a:t>
+                      </a:r>
+                    </a:p>
+                  </a:txBody>
+                </a:tc>
+              </a:tr>
+              <a:tr h="0">
+                <a:tc>
+                  <a:txBody>
+                    <a:bodyPr/>
+                    <a:lstStyle/>
+                    <a:p>
+                      <a:pPr lvl="0" indent="0" marL="0">
+                        <a:buNone/>
+                      </a:pPr>
+                      <a:r>
+                        <a:rPr/>
+                        <a:t>M-%</a:t>
+                      </a:r>
+                    </a:p>
+                  </a:txBody>
+                </a:tc>
+                <a:tc>
+                  <a:txBody>
+                    <a:bodyPr/>
+                    <a:lstStyle/>
+                    <a:p>
+                      <a:pPr lvl="0" indent="0" marL="0">
+                        <a:buNone/>
+                      </a:pPr>
+                      <a:r>
+                        <a:rPr/>
+                        <a:t>Замена с запросом</a:t>
+                      </a:r>
+                    </a:p>
+                  </a:txBody>
+                </a:tc>
+              </a:tr>
+              <a:tr h="0">
+                <a:tc>
+                  <a:txBody>
+                    <a:bodyPr/>
+                    <a:lstStyle/>
+                    <a:p>
+                      <a:pPr lvl="0" indent="0" marL="0">
+                        <a:buNone/>
+                      </a:pPr>
+                      <a:r>
+                        <a:rPr/>
+                        <a:t>C-g</a:t>
+                      </a:r>
+                    </a:p>
+                  </a:txBody>
+                </a:tc>
+                <a:tc>
+                  <a:txBody>
+                    <a:bodyPr/>
+                    <a:lstStyle/>
+                    <a:p>
+                      <a:pPr lvl="0" indent="0" marL="0">
+                        <a:buNone/>
+                      </a:pPr>
+                      <a:r>
+                        <a:rPr/>
+                        <a:t>Отменить операцию</a:t>
+                      </a:r>
+                    </a:p>
+                  </a:txBody>
+                </a:tc>
+              </a:tr>
+              <a:tr h="0">
+                <a:tc>
+                  <a:txBody>
+                    <a:bodyPr/>
+                    <a:lstStyle/>
+                    <a:p>
+                      <a:pPr lvl="0" indent="0" marL="0">
+                        <a:buNone/>
+                      </a:pPr>
+                      <a:r>
+                        <a:rPr/>
+                        <a:t>C-x u (C-/)</a:t>
+                      </a:r>
+                    </a:p>
+                  </a:txBody>
+                </a:tc>
+                <a:tc>
+                  <a:txBody>
+                    <a:bodyPr/>
+                    <a:lstStyle/>
+                    <a:p>
+                      <a:pPr lvl="0" indent="0" marL="0">
+                        <a:buNone/>
+                      </a:pPr>
+                      <a:r>
+                        <a:rPr/>
+                        <a:t>Отменить правку</a:t>
+                      </a:r>
+                    </a:p>
+                  </a:txBody>
+                </a:tc>
+              </a:tr>
+              <a:tr h="0">
+                <a:tc>
+                  <a:txBody>
+                    <a:bodyPr/>
+                    <a:lstStyle/>
+                    <a:p>
+                      <a:pPr lvl="0" indent="0" marL="0">
+                        <a:buNone/>
+                      </a:pPr>
+                      <a:r>
+                        <a:rPr/>
+                        <a:t>C-k</a:t>
+                      </a:r>
+                    </a:p>
+                  </a:txBody>
+                </a:tc>
+                <a:tc>
+                  <a:txBody>
+                    <a:bodyPr/>
+                    <a:lstStyle/>
+                    <a:p>
+                      <a:pPr lvl="0" indent="0" marL="0">
+                        <a:buNone/>
+                      </a:pPr>
+                      <a:r>
+                        <a:rPr/>
+                        <a:t>Вырезать строку</a:t>
+                      </a:r>
+                    </a:p>
+                  </a:txBody>
+                </a:tc>
+              </a:tr>
+              <a:tr h="0">
+                <a:tc>
+                  <a:txBody>
+                    <a:bodyPr/>
+                    <a:lstStyle/>
+                    <a:p>
+                      <a:pPr lvl="0" indent="0" marL="0">
+                        <a:buNone/>
+                      </a:pPr>
+                      <a:r>
+                        <a:rPr/>
+                        <a:t>C-y</a:t>
+                      </a:r>
+                    </a:p>
+                  </a:txBody>
+                </a:tc>
+                <a:tc>
+                  <a:txBody>
+                    <a:bodyPr/>
+                    <a:lstStyle/>
+                    <a:p>
+                      <a:pPr lvl="0" indent="0" marL="0">
+                        <a:buNone/>
+                      </a:pPr>
+                      <a:r>
+                        <a:rPr/>
+                        <a:t>Вставить</a:t>
+                      </a:r>
+                    </a:p>
+                  </a:txBody>
+                </a:tc>
+              </a:tr>
+              <a:tr h="0">
+                <a:tc>
+                  <a:txBody>
+                    <a:bodyPr/>
+                    <a:lstStyle/>
+                    <a:p>
+                      <a:pPr lvl="0" indent="0" marL="0">
+                        <a:buNone/>
+                      </a:pPr>
+                      <a:r>
+                        <a:rPr/>
+                        <a:t>C-space</a:t>
+                      </a:r>
+                    </a:p>
+                  </a:txBody>
+                </a:tc>
+                <a:tc>
+                  <a:txBody>
+                    <a:bodyPr/>
+                    <a:lstStyle/>
+                    <a:p>
+                      <a:pPr lvl="0" indent="0" marL="0">
+                        <a:buNone/>
+                      </a:pPr>
+                      <a:r>
+                        <a:rPr/>
+                        <a:t>Начать выделение</a:t>
+                      </a:r>
+                    </a:p>
+                  </a:txBody>
+                </a:tc>
+              </a:tr>
+              <a:tr h="0">
+                <a:tc>
+                  <a:txBody>
+                    <a:bodyPr/>
+                    <a:lstStyle/>
+                    <a:p>
+                      <a:pPr lvl="0" indent="0" marL="0">
+                        <a:buNone/>
+                      </a:pPr>
+                      <a:r>
+                        <a:rPr/>
+                        <a:t>M-w</a:t>
+                      </a:r>
+                    </a:p>
+                  </a:txBody>
+                </a:tc>
+                <a:tc>
+                  <a:txBody>
+                    <a:bodyPr/>
+                    <a:lstStyle/>
+                    <a:p>
+                      <a:pPr lvl="0" indent="0" marL="0">
+                        <a:buNone/>
+                      </a:pPr>
+                      <a:r>
+                        <a:rPr/>
+                        <a:t>Копировать выделенное</a:t>
+                      </a:r>
+                    </a:p>
+                  </a:txBody>
+                </a:tc>
+              </a:tr>
+              <a:tr h="0">
+                <a:tc>
+                  <a:txBody>
+                    <a:bodyPr/>
+                    <a:lstStyle/>
+                    <a:p>
+                      <a:pPr lvl="0" indent="0" marL="0">
+                        <a:buNone/>
+                      </a:pPr>
+                      <a:r>
+                        <a:rPr/>
+                        <a:t>C-w</a:t>
+                      </a:r>
+                    </a:p>
+                  </a:txBody>
+                </a:tc>
+                <a:tc>
+                  <a:txBody>
+                    <a:bodyPr/>
+                    <a:lstStyle/>
+                    <a:p>
+                      <a:pPr lvl="0" indent="0" marL="0">
+                        <a:buNone/>
+                      </a:pPr>
+                      <a:r>
+                        <a:rPr/>
+                        <a:t>Вырезать выделенное</a:t>
+                      </a:r>
+                    </a:p>
+                  </a:txBody>
+                </a:tc>
+              </a:tr>
+            </a:tbl>
+          </a:graphicData>
+        </a:graphic>
+      </p:graphicFrame>
+    </p:spTree>
+  </p:cSld>
+</p:sld>
+</file>
+
+<file path=ppt/slides/slide5.xml><?xml version="1.0" encoding="utf-8"?>
+<p:sld xmlns:a="http://schemas.openxmlformats.org/drawingml/2006/main" xmlns:r="http://schemas.openxmlformats.org/officeDocument/2006/relationships" xmlns:p="http://schemas.openxmlformats.org/presentationml/2006/main">
+  <p:cSld>
+    <p:spTree>
+      <p:nvGrpSpPr>
+        <p:cNvPr id="1" name=""/>
+        <p:cNvGrpSpPr/>
+        <p:nvPr/>
+      </p:nvGrpSpPr>
+      <p:grpSpPr>
+        <a:xfrm>
+          <a:off x="0" y="0"/>
+          <a:ext cx="0" cy="0"/>
+          <a:chOff x="0" y="0"/>
+          <a:chExt cx="0" cy="0"/>
+        </a:xfrm>
+      </p:grpSpPr>
+      <p:sp>
+        <p:nvSpPr>
+          <p:cNvPr id="2" name="Title 1"/>
+          <p:cNvSpPr>
+            <a:spLocks noGrp="1"/>
+          </p:cNvSpPr>
+          <p:nvPr>
+            <p:ph type="title"/>
+          </p:nvPr>
+        </p:nvSpPr>
+        <p:spPr/>
+        <p:txBody>
+          <a:bodyPr/>
+          <a:lstStyle/>
+          <a:p>
+            <a:pPr lvl="0" indent="0" marL="0">
+              <a:buNone/>
+            </a:pPr>
+            <a:r>
+              <a:rPr/>
+              <a:t>Управление окнами</a:t>
+            </a:r>
+          </a:p>
+        </p:txBody>
+      </p:sp>
+      <p:sp>
+        <p:nvSpPr>
+          <p:cNvPr id="3" name="Content Placeholder 2"/>
+          <p:cNvSpPr>
+            <a:spLocks noGrp="1"/>
+          </p:cNvSpPr>
+          <p:nvPr>
+            <p:ph idx="1"/>
+          </p:nvPr>
+        </p:nvSpPr>
+        <p:spPr/>
+        <p:txBody>
+          <a:bodyPr/>
+          <a:lstStyle/>
+          <a:p>
+            <a:pPr lvl="0"/>
+            <a:r>
+              <a:rPr>
+                <a:latin typeface="Courier"/>
+              </a:rPr>
+              <a:t>C-x 3</a:t>
+            </a:r>
+            <a:r>
+              <a:rPr/>
+              <a:t> → два окна по вертикали</a:t>
+            </a:r>
+          </a:p>
+          <a:p>
+            <a:pPr lvl="0"/>
+            <a:r>
+              <a:rPr>
+                <a:latin typeface="Courier"/>
+              </a:rPr>
+              <a:t>C-x 2</a:t>
+            </a:r>
+            <a:r>
+              <a:rPr/>
+              <a:t> → два окна по горизонтали</a:t>
+            </a:r>
+          </a:p>
+          <a:p>
+            <a:pPr lvl="0"/>
+            <a:r>
+              <a:rPr>
+                <a:latin typeface="Courier"/>
+              </a:rPr>
+              <a:t>C-x 3</a:t>
+            </a:r>
+            <a:r>
+              <a:rPr/>
+              <a:t> puis </a:t>
+            </a:r>
+            <a:r>
+              <a:rPr>
+                <a:latin typeface="Courier"/>
+              </a:rPr>
+              <a:t>C-x 2</a:t>
+            </a:r>
+            <a:r>
+              <a:rPr/>
+              <a:t> dans chaque moitié → </a:t>
+            </a:r>
+            <a:r>
+              <a:rPr b="1"/>
+              <a:t>4 окна</a:t>
+            </a:r>
+          </a:p>
+        </p:txBody>
+      </p:sp>
+      <p:pic>
+        <p:nvPicPr>
+          <p:cNvPr descr="images/emacs_split_windows.png" id="0" name="Picture 1"/>
+          <p:cNvPicPr>
+            <a:picLocks noGrp="1" noChangeAspect="1"/>
+          </p:cNvPicPr>
+          <p:nvPr/>
+        </p:nvPicPr>
+        <p:blipFill>
+          <a:blip r:embed="rId2"/>
+          <a:stretch>
+            <a:fillRect/>
+          </a:stretch>
+        </p:blipFill>
+        <p:spPr bwMode="auto">
+          <a:xfrm>
+            <a:off x="2413000" y="1193800"/>
+            <a:ext cx="4318000" cy="2882900"/>
+          </a:xfrm>
+          <a:prstGeom prst="rect">
+            <a:avLst/>
+          </a:prstGeom>
+          <a:noFill/>
+          <a:ln w="9525">
+            <a:noFill/>
+            <a:headEnd/>
+            <a:tailEnd/>
+          </a:ln>
+        </p:spPr>
+      </p:pic>
+      <p:sp>
+        <p:nvSpPr>
+          <p:cNvPr id="1" name="TextBox 3"/>
+          <p:cNvSpPr txBox="1"/>
+          <p:nvPr/>
+        </p:nvSpPr>
+        <p:spPr>
+          <a:xfrm>
+            <a:off x="457200" y="4076700"/>
+            <a:ext cx="8229600" cy="508000"/>
+          </a:xfrm>
+          <a:prstGeom prst="rect">
+            <a:avLst/>
+          </a:prstGeom>
+          <a:noFill/>
+        </p:spPr>
+        <p:txBody>
+          <a:bodyPr/>
+          <a:lstStyle/>
+          <a:p>
+            <a:pPr lvl="0" indent="0" marL="0" algn="ctr">
+              <a:buNone/>
+            </a:pPr>
+            <a:r>
+              <a:rPr/>
+              <a:t>4 окна Emacs</a:t>
+            </a:r>
+          </a:p>
+        </p:txBody>
+      </p:sp>
+    </p:spTree>
+  </p:cSld>
+</p:sld>
+</file>
+
+<file path=ppt/slides/slide6.xml><?xml version="1.0" encoding="utf-8"?>
+<p:sld xmlns:a="http://schemas.openxmlformats.org/drawingml/2006/main" xmlns:r="http://schemas.openxmlformats.org/officeDocument/2006/relationships" xmlns:p="http://schemas.openxmlformats.org/presentationml/2006/main">
+  <p:cSld>
+    <p:spTree>
+      <p:nvGrpSpPr>
+        <p:cNvPr id="1" name=""/>
+        <p:cNvGrpSpPr/>
+        <p:nvPr/>
+      </p:nvGrpSpPr>
+      <p:grpSpPr>
+        <a:xfrm>
+          <a:off x="0" y="0"/>
+          <a:ext cx="0" cy="0"/>
+          <a:chOff x="0" y="0"/>
+          <a:chExt cx="0" cy="0"/>
+        </a:xfrm>
+      </p:grpSpPr>
+      <p:sp>
+        <p:nvSpPr>
+          <p:cNvPr id="2" name="Title 1"/>
+          <p:cNvSpPr>
+            <a:spLocks noGrp="1"/>
+          </p:cNvSpPr>
+          <p:nvPr>
+            <p:ph type="title"/>
+          </p:nvPr>
+        </p:nvSpPr>
+        <p:spPr>
+          <a:xfrm>
+            <a:off x="457201" y="204787"/>
+            <a:ext cx="3008313" cy="871538"/>
+          </a:xfrm>
+        </p:spPr>
+        <p:txBody>
+          <a:bodyPr/>
+          <a:lstStyle/>
+          <a:p>
+            <a:pPr lvl="0" indent="0" marL="0">
+              <a:buNone/>
+            </a:pPr>
+            <a:r>
+              <a:rPr/>
+              <a:t>Поиск и замена</a:t>
+            </a:r>
+          </a:p>
+        </p:txBody>
+      </p:sp>
+      <p:sp>
+        <p:nvSpPr>
+          <p:cNvPr id="4" name="Text Placeholder 3"/>
+          <p:cNvSpPr>
+            <a:spLocks noGrp="1"/>
+          </p:cNvSpPr>
+          <p:nvPr>
+            <p:ph idx="2" sz="half" type="body"/>
+          </p:nvPr>
+        </p:nvSpPr>
+        <p:spPr/>
+        <p:txBody>
+          <a:bodyPr/>
+          <a:lstStyle/>
+          <a:p>
+            <a:pPr lvl="0"/>
+            <a:r>
+              <a:rPr>
+                <a:latin typeface="Courier"/>
+              </a:rPr>
+              <a:t>C-s</a:t>
+            </a:r>
+            <a:r>
+              <a:rPr/>
+              <a:t> – поиск вперёд</a:t>
+            </a:r>
+          </a:p>
+          <a:p>
+            <a:pPr lvl="0"/>
+            <a:r>
+              <a:rPr>
+                <a:latin typeface="Courier"/>
+              </a:rPr>
+              <a:t>M-%</a:t>
+            </a:r>
+            <a:r>
+              <a:rPr/>
+              <a:t> – замена (что → на что, </a:t>
+            </a:r>
+            <a:r>
+              <a:rPr>
+                <a:latin typeface="Courier"/>
+              </a:rPr>
+              <a:t>!</a:t>
+            </a:r>
+            <a:r>
+              <a:rPr/>
+              <a:t> pour tout remplacer)</a:t>
+            </a:r>
+          </a:p>
+        </p:txBody>
+      </p:sp>
+      <p:pic>
+        <p:nvPicPr>
+          <p:cNvPr descr="images/emacs_search.png" id="0" name="Picture 1"/>
+          <p:cNvPicPr>
+            <a:picLocks noGrp="1" noChangeAspect="1"/>
+          </p:cNvPicPr>
+          <p:nvPr/>
+        </p:nvPicPr>
+        <p:blipFill>
+          <a:blip r:embed="rId2"/>
+          <a:stretch>
+            <a:fillRect/>
+          </a:stretch>
+        </p:blipFill>
+        <p:spPr bwMode="auto">
+          <a:xfrm>
+            <a:off x="3568700" y="431800"/>
+            <a:ext cx="5105400" cy="3403600"/>
+          </a:xfrm>
+          <a:prstGeom prst="rect">
+            <a:avLst/>
+          </a:prstGeom>
+          <a:noFill/>
+          <a:ln w="9525">
+            <a:noFill/>
+            <a:headEnd/>
+            <a:tailEnd/>
+          </a:ln>
+        </p:spPr>
+      </p:pic>
+      <p:sp>
+        <p:nvSpPr>
+          <p:cNvPr id="1" name="TextBox 3"/>
+          <p:cNvSpPr txBox="1"/>
+          <p:nvPr/>
+        </p:nvSpPr>
+        <p:spPr>
+          <a:xfrm>
+            <a:off x="3568700" y="4076700"/>
+            <a:ext cx="5105400" cy="508000"/>
+          </a:xfrm>
+          <a:prstGeom prst="rect">
+            <a:avLst/>
+          </a:prstGeom>
+          <a:noFill/>
+        </p:spPr>
+        <p:txBody>
+          <a:bodyPr/>
+          <a:lstStyle/>
+          <a:p>
+            <a:pPr lvl="0" indent="0" marL="0" algn="ctr">
+              <a:buNone/>
+            </a:pPr>
+            <a:r>
+              <a:rPr/>
+              <a:t>Поиск</a:t>
+            </a:r>
+          </a:p>
+        </p:txBody>
+      </p:sp>
+    </p:spTree>
+  </p:cSld>
+</p:sld>
+</file>
+
+<file path=ppt/slides/slide7.xml><?xml version="1.0" encoding="utf-8"?>
+<p:sld xmlns:a="http://schemas.openxmlformats.org/drawingml/2006/main" xmlns:r="http://schemas.openxmlformats.org/officeDocument/2006/relationships" xmlns:p="http://schemas.openxmlformats.org/presentationml/2006/main">
+  <p:cSld>
+    <p:spTree>
+      <p:nvGrpSpPr>
+        <p:cNvPr id="1" name=""/>
+        <p:cNvGrpSpPr/>
+        <p:nvPr/>
+      </p:nvGrpSpPr>
+      <p:grpSpPr>
+        <a:xfrm>
+          <a:off x="0" y="0"/>
+          <a:ext cx="0" cy="0"/>
+          <a:chOff x="0" y="0"/>
+          <a:chExt cx="0" cy="0"/>
+        </a:xfrm>
+      </p:grpSpPr>
+      <p:sp>
+        <p:nvSpPr>
+          <p:cNvPr id="3" name="Content Placeholder 2"/>
+          <p:cNvSpPr>
+            <a:spLocks noGrp="1"/>
+          </p:cNvSpPr>
+          <p:nvPr>
+            <p:ph idx="1"/>
+          </p:nvPr>
+        </p:nvSpPr>
+        <p:spPr/>
+        <p:txBody>
+          <a:bodyPr/>
+          <a:lstStyle/>
+          <a:p>
+            <a:pPr lvl="0" indent="0" marL="0">
+              <a:buNone/>
+            </a:pPr>
+            <a:r>
+              <a:rPr/>
+              <a:t> Замена</a:t>
+            </a:r>
+          </a:p>
+        </p:txBody>
+      </p:sp>
+    </p:spTree>
+  </p:cSld>
+</p:sld>
+</file>
+
+<file path=ppt/slides/slide8.xml><?xml version="1.0" encoding="utf-8"?>
+<p:sld xmlns:a="http://schemas.openxmlformats.org/drawingml/2006/main" xmlns:r="http://schemas.openxmlformats.org/officeDocument/2006/relationships" xmlns:p="http://schemas.openxmlformats.org/presentationml/2006/main">
+  <p:cSld>
+    <p:spTree>
+      <p:nvGrpSpPr>
+        <p:cNvPr id="1" name=""/>
+        <p:cNvGrpSpPr/>
+        <p:nvPr/>
+      </p:nvGrpSpPr>
+      <p:grpSpPr>
+        <a:xfrm>
+          <a:off x="0" y="0"/>
+          <a:ext cx="0" cy="0"/>
+          <a:chOff x="0" y="0"/>
+          <a:chExt cx="0" cy="0"/>
+        </a:xfrm>
+      </p:grpSpPr>
+      <p:sp>
+        <p:nvSpPr>
+          <p:cNvPr id="2" name="Title 1"/>
+          <p:cNvSpPr>
+            <a:spLocks noGrp="1"/>
+          </p:cNvSpPr>
+          <p:nvPr>
+            <p:ph type="title"/>
+          </p:nvPr>
+        </p:nvSpPr>
+        <p:spPr/>
+        <p:txBody>
+          <a:bodyPr/>
+          <a:lstStyle/>
+          <a:p>
+            <a:pPr lvl="0" indent="0" marL="0">
+              <a:buNone/>
+            </a:pPr>
+            <a:r>
+              <a:rPr/>
+              <a:t>Справка</a:t>
+            </a:r>
+          </a:p>
+        </p:txBody>
+      </p:sp>
+      <p:sp>
+        <p:nvSpPr>
+          <p:cNvPr id="3" name="Content Placeholder 2"/>
+          <p:cNvSpPr>
+            <a:spLocks noGrp="1"/>
+          </p:cNvSpPr>
+          <p:nvPr>
+            <p:ph idx="1"/>
+          </p:nvPr>
+        </p:nvSpPr>
+        <p:spPr/>
+        <p:txBody>
+          <a:bodyPr/>
+          <a:lstStyle/>
+          <a:p>
+            <a:pPr lvl="0"/>
+            <a:r>
+              <a:rPr>
+                <a:latin typeface="Courier"/>
+              </a:rPr>
+              <a:t>C-h t</a:t>
+            </a:r>
+            <a:r>
+              <a:rPr/>
+              <a:t> – учебник</a:t>
+            </a:r>
+          </a:p>
+          <a:p>
+            <a:pPr lvl="0"/>
+            <a:r>
+              <a:rPr>
+                <a:latin typeface="Courier"/>
+              </a:rPr>
+              <a:t>C-h f</a:t>
+            </a:r>
+            <a:r>
+              <a:rPr/>
+              <a:t> – описание функции</a:t>
+            </a:r>
+          </a:p>
+          <a:p>
+            <a:pPr lvl="0"/>
+            <a:r>
+              <a:rPr>
+                <a:latin typeface="Courier"/>
+              </a:rPr>
+              <a:t>C-h k</a:t>
+            </a:r>
+            <a:r>
+              <a:rPr/>
+              <a:t> – описание комбинации клавиш</a:t>
+            </a:r>
+          </a:p>
+          <a:p>
+            <a:pPr lvl="0"/>
+            <a:r>
+              <a:rPr>
+                <a:latin typeface="Courier"/>
+              </a:rPr>
+              <a:t>C-h i</a:t>
+            </a:r>
+            <a:r>
+              <a:rPr/>
+              <a:t> – документация Info</a:t>
+            </a:r>
+          </a:p>
+        </p:txBody>
+      </p:sp>
+    </p:spTree>
+  </p:cSld>
+</p:sld>
+</file>
+
+<file path=ppt/slides/slide9.xml><?xml version="1.0" encoding="utf-8"?>
+<p:sld xmlns:a="http://schemas.openxmlformats.org/drawingml/2006/main" xmlns:r="http://schemas.openxmlformats.org/officeDocument/2006/relationships" xmlns:p="http://schemas.openxmlformats.org/presentationml/2006/main">
+  <p:cSld>
+    <p:spTree>
+      <p:nvGrpSpPr>
+        <p:cNvPr id="1" name=""/>
+        <p:cNvGrpSpPr/>
+        <p:nvPr/>
+      </p:nvGrpSpPr>
+      <p:grpSpPr>
+        <a:xfrm>
+          <a:off x="0" y="0"/>
+          <a:ext cx="0" cy="0"/>
+          <a:chOff x="0" y="0"/>
+          <a:chExt cx="0" cy="0"/>
+        </a:xfrm>
+      </p:grpSpPr>
+      <p:sp>
+        <p:nvSpPr>
+          <p:cNvPr id="2" name="Title 1"/>
+          <p:cNvSpPr>
+            <a:spLocks noGrp="1"/>
+          </p:cNvSpPr>
+          <p:nvPr>
+            <p:ph type="title"/>
+          </p:nvPr>
+        </p:nvSpPr>
+        <p:spPr/>
+        <p:txBody>
+          <a:bodyPr/>
+          <a:lstStyle/>
+          <a:p>
+            <a:pPr lvl="0" indent="0" marL="0">
+              <a:buNone/>
+            </a:pPr>
+            <a:r>
+              <a:rPr/>
+              <a:t>Заключение</a:t>
+            </a:r>
+          </a:p>
+        </p:txBody>
+      </p:sp>
+      <p:sp>
+        <p:nvSpPr>
+          <p:cNvPr id="3" name="Content Placeholder 2"/>
+          <p:cNvSpPr>
+            <a:spLocks noGrp="1"/>
+          </p:cNvSpPr>
+          <p:nvPr>
+            <p:ph idx="1"/>
+          </p:nvPr>
+        </p:nvSpPr>
+        <p:spPr/>
+        <p:txBody>
+          <a:bodyPr/>
+          <a:lstStyle/>
+          <a:p>
+            <a:pPr lvl="0"/>
+            <a:r>
+              <a:rPr/>
+              <a:t>Emacs – очень мощный, но сложный для новичка редактор</a:t>
+            </a:r>
+          </a:p>
+          <a:p>
+            <a:pPr lvl="0"/>
+            <a:r>
+              <a:rPr/>
+              <a:t>Преимущество: расширяемость и огромное количество функций</a:t>
+            </a:r>
+          </a:p>
+          <a:p>
+            <a:pPr lvl="0"/>
+            <a:r>
+              <a:rPr/>
+              <a:t>Требует запоминания многих комбинаций клавиш</a:t>
+            </a:r>
+          </a:p>
+        </p:txBody>
+      </p:sp>
+    </p:spTree>
+  </p:cSld>
+</p:sld>
 </file>
 
 <file path=ppt/theme/theme1.xml><?xml version="1.0" encoding="utf-8"?>

</xml_diff>